<commit_message>
Cover the latest app features in the slide decks
Chapter 01: add a prompt box slide for Retry, prompt history, and voice
dictation, and mention tool permissions on the modes slide.
Chapter 02: mention drag-and-drop file attachments and add a slash
command overview slide.
Chapter 03: mention the Run button on code snippets.

Co-authored-by: Copilot <223556219+Copilot@users.noreply.github.com>
</commit_message>
<xml_diff>
--- a/slides/01-tour-the-app.pptx
+++ b/slides/01-tour-the-app.pptx
@@ -20,9 +20,10 @@
     <p:sldId id="268" r:id="rId14"/>
     <p:sldId id="269" r:id="rId15"/>
     <p:sldId id="270" r:id="rId16"/>
+    <p:sldId id="271" r:id="rId17"/>
   </p:sldIdLst>
   <p:notesMasterIdLst>
-    <p:notesMasterId r:id="rId17"/>
+    <p:notesMasterId r:id="rId18"/>
   </p:notesMasterIdLst>
   <p:sldSz cx="9144000" cy="5143500"/>
   <p:notesSz cx="5143500" cy="9144000"/>
@@ -1044,7 +1045,7 @@
           <a:p>
             <a:r>
               <a:rPr lang="en-US" dirty="0"/>
-              <a:t>Recap the chapter. Keep the model and effort defaults for simple tasks. Next, Chapter 02 solves the shared working copy problem with isolated worktree sessions and focused context with @, #, and /.</a:t>
+              <a:t>Three features save time in the prompt box. If a response does not work for you, select Retry below it and pick a different model, reasoning effort, or context window. You do not retype the prompt. Press Ctrl+R, or Cmd+R on macOS, to open your prompt history across all sessions. Search it and select a prompt to reuse it. Voice dictation is on by default. It turns speech into prompt text that you can edit before you send it. You can change the microphone and transcription model in Settings, Voice dictation, and the operating system must allow microphone access.</a:t>
             </a:r>
             <a:endParaRPr lang="en-US" dirty="0"/>
           </a:p>
@@ -1068,6 +1069,94 @@
             <a:fld id="{F7021451-1387-4CA6-816F-3879F97B5CBC}" type="slidenum">
               <a:rPr lang="en-US"/>
               <a:t>15</a:t>
+            </a:fld>
+            <a:endParaRPr lang="en-US"/>
+          </a:p>
+        </p:txBody>
+      </p:sp>
+    </p:spTree>
+    <p:extLst>
+      <p:ext uri="{BB962C8B-B14F-4D97-AF65-F5344CB8AC3E}">
+        <p14:creationId xmlns:p14="http://schemas.microsoft.com/office/powerpoint/2010/main" val="1024086991"/>
+      </p:ext>
+    </p:extLst>
+  </p:cSld>
+  <p:clrMapOvr>
+    <a:masterClrMapping/>
+  </p:clrMapOvr>
+</p:notes>
+</file>
+
+<file path=ppt/notesSlides/notesSlide16.xml><?xml version="1.0" encoding="utf-8"?>
+<p:notes xmlns:a="http://schemas.openxmlformats.org/drawingml/2006/main" xmlns:r="http://schemas.openxmlformats.org/officeDocument/2006/relationships" xmlns:p="http://schemas.openxmlformats.org/presentationml/2006/main">
+  <p:cSld>
+    <p:spTree>
+      <p:nvGrpSpPr>
+        <p:cNvPr id="1" name=""/>
+        <p:cNvGrpSpPr/>
+        <p:nvPr/>
+      </p:nvGrpSpPr>
+      <p:grpSpPr>
+        <a:xfrm>
+          <a:off x="0" y="0"/>
+          <a:ext cx="0" cy="0"/>
+          <a:chOff x="0" y="0"/>
+          <a:chExt cx="0" cy="0"/>
+        </a:xfrm>
+      </p:grpSpPr>
+      <p:sp>
+        <p:nvSpPr>
+          <p:cNvPr id="2" name="Slide Image Placeholder 1"/>
+          <p:cNvSpPr>
+            <a:spLocks noGrp="1" noRot="1" noChangeAspect="1"/>
+          </p:cNvSpPr>
+          <p:nvPr>
+            <p:ph type="sldImg"/>
+          </p:nvPr>
+        </p:nvSpPr>
+        <p:spPr/>
+      </p:sp>
+      <p:sp>
+        <p:nvSpPr>
+          <p:cNvPr id="3" name="Notes Placeholder 2"/>
+          <p:cNvSpPr>
+            <a:spLocks noGrp="1"/>
+          </p:cNvSpPr>
+          <p:nvPr>
+            <p:ph type="body" idx="1"/>
+          </p:nvPr>
+        </p:nvSpPr>
+        <p:spPr/>
+        <p:txBody>
+          <a:bodyPr/>
+          <a:lstStyle/>
+          <a:p>
+            <a:r>
+              <a:rPr lang="en-US" dirty="0"/>
+              <a:t>Recap the chapter. Keep the model and effort defaults for simple tasks. Next, Chapter 02 solves the shared working copy problem with isolated worktree sessions and focused context with @, #, and /.</a:t>
+            </a:r>
+            <a:endParaRPr lang="en-US" dirty="0"/>
+          </a:p>
+        </p:txBody>
+      </p:sp>
+      <p:sp>
+        <p:nvSpPr>
+          <p:cNvPr id="4" name="Slide Number Placeholder 3"/>
+          <p:cNvSpPr>
+            <a:spLocks noGrp="1"/>
+          </p:cNvSpPr>
+          <p:nvPr>
+            <p:ph type="sldNum" sz="quarter" idx="10"/>
+          </p:nvPr>
+        </p:nvSpPr>
+        <p:spPr/>
+        <p:txBody>
+          <a:bodyPr/>
+          <a:lstStyle/>
+          <a:p>
+            <a:fld id="{F7021451-1387-4CA6-816F-3879F97B5CBC}" type="slidenum">
+              <a:rPr lang="en-US"/>
+              <a:t>16</a:t>
             </a:fld>
             <a:endParaRPr lang="en-US"/>
           </a:p>
@@ -5480,52 +5569,7 @@
         </p:nvSpPr>
         <p:spPr>
           <a:xfrm>
-            <a:off x="507950" y="1104751"/>
-            <a:ext cx="8161020" cy="254050"/>
-          </a:xfrm>
-          <a:prstGeom prst="rect">
-            <a:avLst/>
-          </a:prstGeom>
-          <a:noFill/>
-          <a:ln/>
-        </p:spPr>
-        <p:txBody>
-          <a:bodyPr wrap="square" lIns="0" tIns="0" rIns="0" bIns="0" rtlCol="0" anchor="t"/>
-          <a:lstStyle/>
-          <a:p>
-            <a:pPr algn="l" indent="0" marL="0">
-              <a:lnSpc>
-                <a:spcPts val="2000"/>
-              </a:lnSpc>
-              <a:spcBef>
-                <a:spcPts val="500"/>
-              </a:spcBef>
-              <a:buNone/>
-            </a:pPr>
-            <a:r>
-              <a:rPr lang="en-US" sz="1650" dirty="0">
-                <a:solidFill>
-                  <a:srgbClr val="59636E"/>
-                </a:solidFill>
-                <a:latin typeface="Arial" pitchFamily="34" charset="0"/>
-                <a:ea typeface="Arial" pitchFamily="34" charset="-122"/>
-                <a:cs typeface="Arial" pitchFamily="34" charset="-120"/>
-              </a:rPr>
-              <a:t>More autonomy from left to right. Pick what fits.</a:t>
-            </a:r>
-            <a:endParaRPr lang="en-US" sz="1650" dirty="0"/>
-          </a:p>
-        </p:txBody>
-      </p:sp>
-      <p:sp>
-        <p:nvSpPr>
-          <p:cNvPr id="9" name="Text 5"/>
-          <p:cNvSpPr/>
-          <p:nvPr/>
-        </p:nvSpPr>
-        <p:spPr>
-          <a:xfrm>
-            <a:off x="511076" y="1874490"/>
+            <a:off x="511076" y="1569690"/>
             <a:ext cx="3549551" cy="2397621"/>
           </a:xfrm>
           <a:prstGeom prst="roundRect">
@@ -5562,7 +5606,7 @@
       </p:sp>
       <p:pic>
         <p:nvPicPr>
-          <p:cNvPr id="10" name="Image 2" descr="/Users/danwahlin/.copilot/session-state/56a7a0da-def8-48d4-b5e8-0ac3878cb8dd/files/slides-build/img/01-session-mode-decision-ladder.jpg">    </p:cNvPr>
+          <p:cNvPr id="9" name="Image 2" descr="/Users/danwahlin/.copilot/session-state/56a7a0da-def8-48d4-b5e8-0ac3878cb8dd/files/slides-build/img/01-session-mode-decision-ladder.jpg">    </p:cNvPr>
           <p:cNvPicPr>
             <a:picLocks noChangeAspect="1"/>
           </p:cNvPicPr>
@@ -5576,7 +5620,7 @@
         </p:blipFill>
         <p:spPr>
           <a:xfrm>
-            <a:off x="558701" y="1922115"/>
+            <a:off x="558701" y="1617315"/>
             <a:ext cx="3454301" cy="2302371"/>
           </a:xfrm>
           <a:prstGeom prst="rect">
@@ -5586,18 +5630,18 @@
       </p:pic>
       <p:sp>
         <p:nvSpPr>
-          <p:cNvPr id="11" name="Text 6"/>
-          <p:cNvSpPr/>
-          <p:nvPr/>
-        </p:nvSpPr>
-        <p:spPr>
-          <a:xfrm>
-            <a:off x="4317802" y="1567458"/>
-            <a:ext cx="4318099" cy="919311"/>
+          <p:cNvPr id="10" name="Text 5"/>
+          <p:cNvSpPr/>
+          <p:nvPr/>
+        </p:nvSpPr>
+        <p:spPr>
+          <a:xfrm>
+            <a:off x="4317802" y="1244501"/>
+            <a:ext cx="4318099" cy="898773"/>
           </a:xfrm>
           <a:prstGeom prst="roundRect">
             <a:avLst>
-              <a:gd name="adj" fmla="val 13815"/>
+              <a:gd name="adj" fmla="val 14130"/>
             </a:avLst>
           </a:prstGeom>
           <a:solidFill>
@@ -5622,13 +5666,13 @@
       </p:sp>
       <p:sp>
         <p:nvSpPr>
-          <p:cNvPr id="12" name="Text 7"/>
-          <p:cNvSpPr/>
-          <p:nvPr/>
-        </p:nvSpPr>
-        <p:spPr>
-          <a:xfrm>
-            <a:off x="4454277" y="1703933"/>
+          <p:cNvPr id="11" name="Text 6"/>
+          <p:cNvSpPr/>
+          <p:nvPr/>
+        </p:nvSpPr>
+        <p:spPr>
+          <a:xfrm>
+            <a:off x="4428827" y="1355527"/>
             <a:ext cx="381000" cy="381000"/>
           </a:xfrm>
           <a:prstGeom prst="roundRect">
@@ -5654,7 +5698,7 @@
       </p:sp>
       <p:pic>
         <p:nvPicPr>
-          <p:cNvPr id="13" name="Image 3" descr="/Users/danwahlin/.copilot/session-state/56a7a0da-def8-48d4-b5e8-0ac3878cb8dd/files/slides-build/icons/GoPerson-0969DA.png">    </p:cNvPr>
+          <p:cNvPr id="12" name="Image 3" descr="/Users/danwahlin/.copilot/session-state/56a7a0da-def8-48d4-b5e8-0ac3878cb8dd/files/slides-build/icons/GoPerson-0969DA.png">    </p:cNvPr>
           <p:cNvPicPr>
             <a:picLocks noChangeAspect="1"/>
           </p:cNvPicPr>
@@ -5668,7 +5712,7 @@
         </p:blipFill>
         <p:spPr>
           <a:xfrm>
-            <a:off x="4536877" y="1786533"/>
+            <a:off x="4511427" y="1438126"/>
             <a:ext cx="215801" cy="215801"/>
           </a:xfrm>
           <a:prstGeom prst="rect">
@@ -5678,13 +5722,13 @@
       </p:pic>
       <p:sp>
         <p:nvSpPr>
-          <p:cNvPr id="14" name="Text 8"/>
-          <p:cNvSpPr/>
-          <p:nvPr/>
-        </p:nvSpPr>
-        <p:spPr>
-          <a:xfrm>
-            <a:off x="4949577" y="1780133"/>
+          <p:cNvPr id="13" name="Text 7"/>
+          <p:cNvSpPr/>
+          <p:nvPr/>
+        </p:nvSpPr>
+        <p:spPr>
+          <a:xfrm>
+            <a:off x="4924127" y="1431727"/>
             <a:ext cx="1069312" cy="228600"/>
           </a:xfrm>
           <a:prstGeom prst="rect">
@@ -5720,14 +5764,14 @@
       </p:sp>
       <p:sp>
         <p:nvSpPr>
-          <p:cNvPr id="15" name="Text 9"/>
-          <p:cNvSpPr/>
-          <p:nvPr/>
-        </p:nvSpPr>
-        <p:spPr>
-          <a:xfrm>
-            <a:off x="4454277" y="2135684"/>
-            <a:ext cx="4126051" cy="214610"/>
+          <p:cNvPr id="14" name="Text 8"/>
+          <p:cNvSpPr/>
+          <p:nvPr/>
+        </p:nvSpPr>
+        <p:spPr>
+          <a:xfrm>
+            <a:off x="4428827" y="1761827"/>
+            <a:ext cx="4177969" cy="214610"/>
           </a:xfrm>
           <a:prstGeom prst="rect">
             <a:avLst/>
@@ -5762,18 +5806,18 @@
       </p:sp>
       <p:sp>
         <p:nvSpPr>
-          <p:cNvPr id="16" name="Text 10"/>
-          <p:cNvSpPr/>
-          <p:nvPr/>
-        </p:nvSpPr>
-        <p:spPr>
-          <a:xfrm>
-            <a:off x="4317802" y="2613720"/>
-            <a:ext cx="4318099" cy="919311"/>
+          <p:cNvPr id="15" name="Text 9"/>
+          <p:cNvSpPr/>
+          <p:nvPr/>
+        </p:nvSpPr>
+        <p:spPr>
+          <a:xfrm>
+            <a:off x="4317802" y="2219474"/>
+            <a:ext cx="4318099" cy="898773"/>
           </a:xfrm>
           <a:prstGeom prst="roundRect">
             <a:avLst>
-              <a:gd name="adj" fmla="val 13815"/>
+              <a:gd name="adj" fmla="val 14130"/>
             </a:avLst>
           </a:prstGeom>
           <a:solidFill>
@@ -5798,13 +5842,13 @@
       </p:sp>
       <p:sp>
         <p:nvSpPr>
-          <p:cNvPr id="17" name="Text 11"/>
-          <p:cNvSpPr/>
-          <p:nvPr/>
-        </p:nvSpPr>
-        <p:spPr>
-          <a:xfrm>
-            <a:off x="4454277" y="2750195"/>
+          <p:cNvPr id="16" name="Text 10"/>
+          <p:cNvSpPr/>
+          <p:nvPr/>
+        </p:nvSpPr>
+        <p:spPr>
+          <a:xfrm>
+            <a:off x="4428827" y="2330500"/>
             <a:ext cx="381000" cy="381000"/>
           </a:xfrm>
           <a:prstGeom prst="roundRect">
@@ -5830,7 +5874,7 @@
       </p:sp>
       <p:pic>
         <p:nvPicPr>
-          <p:cNvPr id="18" name="Image 4" descr="/Users/danwahlin/.copilot/session-state/56a7a0da-def8-48d4-b5e8-0ac3878cb8dd/files/slides-build/icons/GoChecklist-8250DF.png">    </p:cNvPr>
+          <p:cNvPr id="17" name="Image 4" descr="/Users/danwahlin/.copilot/session-state/56a7a0da-def8-48d4-b5e8-0ac3878cb8dd/files/slides-build/icons/GoChecklist-8250DF.png">    </p:cNvPr>
           <p:cNvPicPr>
             <a:picLocks noChangeAspect="1"/>
           </p:cNvPicPr>
@@ -5844,7 +5888,7 @@
         </p:blipFill>
         <p:spPr>
           <a:xfrm>
-            <a:off x="4536877" y="2832795"/>
+            <a:off x="4511427" y="2413099"/>
             <a:ext cx="215801" cy="215801"/>
           </a:xfrm>
           <a:prstGeom prst="rect">
@@ -5854,13 +5898,13 @@
       </p:pic>
       <p:sp>
         <p:nvSpPr>
-          <p:cNvPr id="19" name="Text 12"/>
-          <p:cNvSpPr/>
-          <p:nvPr/>
-        </p:nvSpPr>
-        <p:spPr>
-          <a:xfrm>
-            <a:off x="4949577" y="2826395"/>
+          <p:cNvPr id="18" name="Text 11"/>
+          <p:cNvSpPr/>
+          <p:nvPr/>
+        </p:nvSpPr>
+        <p:spPr>
+          <a:xfrm>
+            <a:off x="4924127" y="2406700"/>
             <a:ext cx="451467" cy="228600"/>
           </a:xfrm>
           <a:prstGeom prst="rect">
@@ -5896,14 +5940,14 @@
       </p:sp>
       <p:sp>
         <p:nvSpPr>
-          <p:cNvPr id="20" name="Text 13"/>
-          <p:cNvSpPr/>
-          <p:nvPr/>
-        </p:nvSpPr>
-        <p:spPr>
-          <a:xfrm>
-            <a:off x="4454277" y="3181945"/>
-            <a:ext cx="4126051" cy="214610"/>
+          <p:cNvPr id="19" name="Text 12"/>
+          <p:cNvSpPr/>
+          <p:nvPr/>
+        </p:nvSpPr>
+        <p:spPr>
+          <a:xfrm>
+            <a:off x="4428827" y="2736800"/>
+            <a:ext cx="4177969" cy="214610"/>
           </a:xfrm>
           <a:prstGeom prst="rect">
             <a:avLst/>
@@ -5938,18 +5982,18 @@
       </p:sp>
       <p:sp>
         <p:nvSpPr>
-          <p:cNvPr id="21" name="Text 14"/>
-          <p:cNvSpPr/>
-          <p:nvPr/>
-        </p:nvSpPr>
-        <p:spPr>
-          <a:xfrm>
-            <a:off x="4317802" y="3659981"/>
-            <a:ext cx="4318099" cy="919311"/>
+          <p:cNvPr id="20" name="Text 13"/>
+          <p:cNvSpPr/>
+          <p:nvPr/>
+        </p:nvSpPr>
+        <p:spPr>
+          <a:xfrm>
+            <a:off x="4317802" y="3194447"/>
+            <a:ext cx="4318099" cy="898773"/>
           </a:xfrm>
           <a:prstGeom prst="roundRect">
             <a:avLst>
-              <a:gd name="adj" fmla="val 13815"/>
+              <a:gd name="adj" fmla="val 14130"/>
             </a:avLst>
           </a:prstGeom>
           <a:solidFill>
@@ -5974,13 +6018,13 @@
       </p:sp>
       <p:sp>
         <p:nvSpPr>
-          <p:cNvPr id="22" name="Text 15"/>
-          <p:cNvSpPr/>
-          <p:nvPr/>
-        </p:nvSpPr>
-        <p:spPr>
-          <a:xfrm>
-            <a:off x="4454277" y="3796457"/>
+          <p:cNvPr id="21" name="Text 14"/>
+          <p:cNvSpPr/>
+          <p:nvPr/>
+        </p:nvSpPr>
+        <p:spPr>
+          <a:xfrm>
+            <a:off x="4428827" y="3305473"/>
             <a:ext cx="381000" cy="381000"/>
           </a:xfrm>
           <a:prstGeom prst="roundRect">
@@ -6006,7 +6050,7 @@
       </p:sp>
       <p:pic>
         <p:nvPicPr>
-          <p:cNvPr id="23" name="Image 5" descr="/Users/danwahlin/.copilot/session-state/56a7a0da-def8-48d4-b5e8-0ac3878cb8dd/files/slides-build/icons/GoRocket-1A7F37.png">    </p:cNvPr>
+          <p:cNvPr id="22" name="Image 5" descr="/Users/danwahlin/.copilot/session-state/56a7a0da-def8-48d4-b5e8-0ac3878cb8dd/files/slides-build/icons/GoRocket-1A7F37.png">    </p:cNvPr>
           <p:cNvPicPr>
             <a:picLocks noChangeAspect="1"/>
           </p:cNvPicPr>
@@ -6020,7 +6064,7 @@
         </p:blipFill>
         <p:spPr>
           <a:xfrm>
-            <a:off x="4536877" y="3879056"/>
+            <a:off x="4511427" y="3388072"/>
             <a:ext cx="215801" cy="215801"/>
           </a:xfrm>
           <a:prstGeom prst="rect">
@@ -6030,13 +6074,13 @@
       </p:pic>
       <p:sp>
         <p:nvSpPr>
-          <p:cNvPr id="24" name="Text 16"/>
-          <p:cNvSpPr/>
-          <p:nvPr/>
-        </p:nvSpPr>
-        <p:spPr>
-          <a:xfrm>
-            <a:off x="4949577" y="3872657"/>
+          <p:cNvPr id="23" name="Text 15"/>
+          <p:cNvSpPr/>
+          <p:nvPr/>
+        </p:nvSpPr>
+        <p:spPr>
+          <a:xfrm>
+            <a:off x="4924127" y="3381673"/>
             <a:ext cx="937849" cy="228600"/>
           </a:xfrm>
           <a:prstGeom prst="rect">
@@ -6072,14 +6116,14 @@
       </p:sp>
       <p:sp>
         <p:nvSpPr>
-          <p:cNvPr id="25" name="Text 17"/>
-          <p:cNvSpPr/>
-          <p:nvPr/>
-        </p:nvSpPr>
-        <p:spPr>
-          <a:xfrm>
-            <a:off x="4454277" y="4228207"/>
-            <a:ext cx="4126051" cy="214610"/>
+          <p:cNvPr id="24" name="Text 16"/>
+          <p:cNvSpPr/>
+          <p:nvPr/>
+        </p:nvSpPr>
+        <p:spPr>
+          <a:xfrm>
+            <a:off x="4428827" y="3711773"/>
+            <a:ext cx="4177969" cy="214610"/>
           </a:xfrm>
           <a:prstGeom prst="rect">
             <a:avLst/>
@@ -6109,6 +6153,125 @@
               <a:t>Well-defined tasks, clear outcomes.</a:t>
             </a:r>
             <a:endParaRPr lang="en-US" sz="1400" dirty="0"/>
+          </a:p>
+        </p:txBody>
+      </p:sp>
+      <p:sp>
+        <p:nvSpPr>
+          <p:cNvPr id="25" name="Text 17"/>
+          <p:cNvSpPr/>
+          <p:nvPr/>
+        </p:nvSpPr>
+        <p:spPr>
+          <a:xfrm>
+            <a:off x="4317802" y="4169420"/>
+            <a:ext cx="4318099" cy="478631"/>
+          </a:xfrm>
+          <a:prstGeom prst="roundRect">
+            <a:avLst>
+              <a:gd name="adj" fmla="val 21227"/>
+            </a:avLst>
+          </a:prstGeom>
+          <a:solidFill>
+            <a:srgbClr val="DDF4FF"/>
+          </a:solidFill>
+          <a:ln w="9525">
+            <a:solidFill>
+              <a:srgbClr val="9CD7FF"/>
+            </a:solidFill>
+          </a:ln>
+        </p:spPr>
+        <p:txBody>
+          <a:bodyPr wrap="square" rtlCol="0" anchor="ctr"/>
+          <a:lstStyle/>
+          <a:p>
+            <a:pPr indent="0" marL="0">
+              <a:buNone/>
+            </a:pPr>
+            <a:endParaRPr lang="en-US" dirty="0"/>
+          </a:p>
+        </p:txBody>
+      </p:sp>
+      <p:pic>
+        <p:nvPicPr>
+          <p:cNvPr id="26" name="Image 6" descr="/Users/danwahlin/.copilot/session-state/56a7a0da-def8-48d4-b5e8-0ac3878cb8dd/files/slides-build/icons/GoShieldCheck-0969DA.png">    </p:cNvPr>
+          <p:cNvPicPr>
+            <a:picLocks noChangeAspect="1"/>
+          </p:cNvPicPr>
+          <p:nvPr/>
+        </p:nvPicPr>
+        <p:blipFill>
+          <a:blip r:embed="rId8"/>
+          <a:stretch>
+            <a:fillRect/>
+          </a:stretch>
+        </p:blipFill>
+        <p:spPr>
+          <a:xfrm>
+            <a:off x="4505027" y="4307086"/>
+            <a:ext cx="203150" cy="203150"/>
+          </a:xfrm>
+          <a:prstGeom prst="rect">
+            <a:avLst/>
+          </a:prstGeom>
+        </p:spPr>
+      </p:pic>
+      <p:sp>
+        <p:nvSpPr>
+          <p:cNvPr id="27" name="Text 18"/>
+          <p:cNvSpPr/>
+          <p:nvPr/>
+        </p:nvSpPr>
+        <p:spPr>
+          <a:xfrm>
+            <a:off x="4835128" y="4305895"/>
+            <a:ext cx="2853928" cy="205680"/>
+          </a:xfrm>
+          <a:prstGeom prst="rect">
+            <a:avLst/>
+          </a:prstGeom>
+          <a:noFill/>
+          <a:ln/>
+        </p:spPr>
+        <p:txBody>
+          <a:bodyPr wrap="square" lIns="0" tIns="0" rIns="0" bIns="0" rtlCol="0" anchor="t"/>
+          <a:lstStyle/>
+          <a:p>
+            <a:pPr algn="l" indent="0" marL="0">
+              <a:lnSpc>
+                <a:spcPts val="1620"/>
+              </a:lnSpc>
+              <a:buNone/>
+            </a:pPr>
+            <a:r>
+              <a:rPr lang="en-US" sz="1350" b="1" dirty="0">
+                <a:solidFill>
+                  <a:srgbClr val="1F2328"/>
+                </a:solidFill>
+                <a:latin typeface="Arial" pitchFamily="34" charset="0"/>
+                <a:ea typeface="Arial" pitchFamily="34" charset="-122"/>
+                <a:cs typeface="Arial" pitchFamily="34" charset="-120"/>
+              </a:rPr>
+              <a:t>Tool permissions:</a:t>
+            </a:r>
+            <a:pPr algn="l" indent="0" marL="0">
+              <a:lnSpc>
+                <a:spcPts val="1620"/>
+              </a:lnSpc>
+              <a:buNone/>
+            </a:pPr>
+            <a:r>
+              <a:rPr lang="en-US" sz="1350" dirty="0">
+                <a:solidFill>
+                  <a:srgbClr val="1F2328"/>
+                </a:solidFill>
+                <a:latin typeface="Arial" pitchFamily="34" charset="0"/>
+                <a:ea typeface="Arial" pitchFamily="34" charset="-122"/>
+                <a:cs typeface="Arial" pitchFamily="34" charset="-120"/>
+              </a:rPr>
+              <a:t> when to ask first.</a:t>
+            </a:r>
+            <a:endParaRPr lang="en-US" sz="1350" dirty="0"/>
           </a:p>
         </p:txBody>
       </p:sp>
@@ -7229,6 +7392,918 @@
 <file path=ppt/slides/slide15.xml><?xml version="1.0" encoding="utf-8"?>
 <p:sld xmlns:a="http://schemas.openxmlformats.org/drawingml/2006/main" xmlns:r="http://schemas.openxmlformats.org/officeDocument/2006/relationships" xmlns:p="http://schemas.openxmlformats.org/presentationml/2006/main">
   <p:cSld name="Slide 15">
+    <p:bg>
+      <p:bgPr>
+        <a:solidFill>
+          <a:srgbClr val="FFFFFF"/>
+        </a:solidFill>
+      </p:bgPr>
+    </p:bg>
+    <p:spTree>
+      <p:nvGrpSpPr>
+        <p:cNvPr id="1" name=""/>
+        <p:cNvGrpSpPr/>
+        <p:nvPr/>
+      </p:nvGrpSpPr>
+      <p:grpSpPr>
+        <a:xfrm>
+          <a:off x="0" y="0"/>
+          <a:ext cx="0" cy="0"/>
+          <a:chOff x="0" y="0"/>
+          <a:chExt cx="0" cy="0"/>
+        </a:xfrm>
+      </p:grpSpPr>
+      <p:pic>
+        <p:nvPicPr>
+          <p:cNvPr id="2" name="Image 0" descr="/Users/danwahlin/.copilot/session-state/56a7a0da-def8-48d4-b5e8-0ac3878cb8dd/files/slides-build/img/grad-corner-pattern.png">    </p:cNvPr>
+          <p:cNvPicPr>
+            <a:picLocks noChangeAspect="1"/>
+          </p:cNvPicPr>
+          <p:nvPr/>
+        </p:nvPicPr>
+        <p:blipFill>
+          <a:blip r:embed="rId1"/>
+          <a:stretch>
+            <a:fillRect/>
+          </a:stretch>
+        </p:blipFill>
+        <p:spPr>
+          <a:xfrm>
+            <a:off x="6349901" y="0"/>
+            <a:ext cx="2793950" cy="1308050"/>
+          </a:xfrm>
+          <a:prstGeom prst="rect">
+            <a:avLst/>
+          </a:prstGeom>
+        </p:spPr>
+      </p:pic>
+      <p:sp>
+        <p:nvSpPr>
+          <p:cNvPr id="3" name="Text 0"/>
+          <p:cNvSpPr/>
+          <p:nvPr/>
+        </p:nvSpPr>
+        <p:spPr>
+          <a:xfrm>
+            <a:off x="7340501" y="177701"/>
+            <a:ext cx="1168301" cy="279350"/>
+          </a:xfrm>
+          <a:prstGeom prst="roundRect">
+            <a:avLst>
+              <a:gd name="adj" fmla="val 22731"/>
+            </a:avLst>
+          </a:prstGeom>
+          <a:solidFill>
+            <a:srgbClr val="1A7F37"/>
+          </a:solidFill>
+          <a:ln/>
+        </p:spPr>
+        <p:txBody>
+          <a:bodyPr wrap="square" rtlCol="0" anchor="ctr"/>
+          <a:lstStyle/>
+          <a:p>
+            <a:pPr indent="0" marL="0">
+              <a:buNone/>
+            </a:pPr>
+            <a:endParaRPr lang="en-US" dirty="0"/>
+          </a:p>
+        </p:txBody>
+      </p:sp>
+      <p:sp>
+        <p:nvSpPr>
+          <p:cNvPr id="4" name="Text 1"/>
+          <p:cNvSpPr/>
+          <p:nvPr/>
+        </p:nvSpPr>
+        <p:spPr>
+          <a:xfrm>
+            <a:off x="7461041" y="231577"/>
+            <a:ext cx="927071" cy="171450"/>
+          </a:xfrm>
+          <a:prstGeom prst="rect">
+            <a:avLst/>
+          </a:prstGeom>
+          <a:noFill/>
+          <a:ln/>
+        </p:spPr>
+        <p:txBody>
+          <a:bodyPr wrap="square" lIns="0" tIns="0" rIns="0" bIns="0" rtlCol="0" anchor="t"/>
+          <a:lstStyle/>
+          <a:p>
+            <a:pPr algn="ctr" indent="0" marL="0">
+              <a:buNone/>
+            </a:pPr>
+            <a:r>
+              <a:rPr lang="en-US" sz="1150" b="1" dirty="0">
+                <a:solidFill>
+                  <a:srgbClr val="FFFFFF"/>
+                </a:solidFill>
+                <a:latin typeface="Arial" pitchFamily="34" charset="0"/>
+                <a:ea typeface="Arial" pitchFamily="34" charset="-122"/>
+                <a:cs typeface="Arial" pitchFamily="34" charset="-120"/>
+              </a:rPr>
+              <a:t>CHAPTER 01</a:t>
+            </a:r>
+            <a:endParaRPr lang="en-US" sz="1150" dirty="0"/>
+          </a:p>
+        </p:txBody>
+      </p:sp>
+      <p:pic>
+        <p:nvPicPr>
+          <p:cNvPr id="5" name="Image 1" descr="/Users/danwahlin/.copilot/session-state/56a7a0da-def8-48d4-b5e8-0ac3878cb8dd/files/slides-build/icons/FaGithub-1F2328.png">
+            <a:hlinkClick r:id="rId3" tooltip="https://github.com/github/copilot-app-for-beginners/tree/main/01-tour-the-app"/>
+          </p:cNvPr>
+          <p:cNvPicPr>
+            <a:picLocks noChangeAspect="1"/>
+          </p:cNvPicPr>
+          <p:nvPr/>
+        </p:nvPicPr>
+        <p:blipFill>
+          <a:blip r:embed="rId2"/>
+          <a:stretch>
+            <a:fillRect/>
+          </a:stretch>
+        </p:blipFill>
+        <p:spPr>
+          <a:xfrm>
+            <a:off x="8610600" y="165050"/>
+            <a:ext cx="304800" cy="304800"/>
+          </a:xfrm>
+          <a:prstGeom prst="rect">
+            <a:avLst/>
+          </a:prstGeom>
+        </p:spPr>
+      </p:pic>
+      <p:sp>
+        <p:nvSpPr>
+          <p:cNvPr id="6" name="Text 2"/>
+          <p:cNvSpPr/>
+          <p:nvPr/>
+        </p:nvSpPr>
+        <p:spPr>
+          <a:xfrm>
+            <a:off x="507950" y="381000"/>
+            <a:ext cx="8161020" cy="190500"/>
+          </a:xfrm>
+          <a:prstGeom prst="rect">
+            <a:avLst/>
+          </a:prstGeom>
+          <a:noFill/>
+          <a:ln/>
+        </p:spPr>
+        <p:txBody>
+          <a:bodyPr wrap="square" lIns="0" tIns="0" rIns="0" bIns="0" rtlCol="0" anchor="t"/>
+          <a:lstStyle/>
+          <a:p>
+            <a:pPr algn="l" indent="0" marL="0">
+              <a:buNone/>
+            </a:pPr>
+            <a:r>
+              <a:rPr lang="en-US" sz="1250" b="1" dirty="0">
+                <a:solidFill>
+                  <a:srgbClr val="1A7F37"/>
+                </a:solidFill>
+                <a:latin typeface="Arial" pitchFamily="34" charset="0"/>
+                <a:ea typeface="Arial" pitchFamily="34" charset="-122"/>
+                <a:cs typeface="Arial" pitchFamily="34" charset="-120"/>
+              </a:rPr>
+              <a:t>PROMPT BOX SHORTCUTS</a:t>
+            </a:r>
+            <a:endParaRPr lang="en-US" sz="1250" dirty="0"/>
+          </a:p>
+        </p:txBody>
+      </p:sp>
+      <p:sp>
+        <p:nvSpPr>
+          <p:cNvPr id="7" name="Text 3"/>
+          <p:cNvSpPr/>
+          <p:nvPr/>
+        </p:nvSpPr>
+        <p:spPr>
+          <a:xfrm>
+            <a:off x="507950" y="622250"/>
+            <a:ext cx="8161020" cy="419100"/>
+          </a:xfrm>
+          <a:prstGeom prst="rect">
+            <a:avLst/>
+          </a:prstGeom>
+          <a:noFill/>
+          <a:ln/>
+        </p:spPr>
+        <p:txBody>
+          <a:bodyPr wrap="square" lIns="0" tIns="0" rIns="0" bIns="0" rtlCol="0" anchor="t"/>
+          <a:lstStyle/>
+          <a:p>
+            <a:pPr algn="l" indent="0" marL="0">
+              <a:lnSpc>
+                <a:spcPts val="3300"/>
+              </a:lnSpc>
+              <a:spcBef>
+                <a:spcPts val="400"/>
+              </a:spcBef>
+              <a:buNone/>
+            </a:pPr>
+            <a:r>
+              <a:rPr lang="en-US" sz="2800" b="1" dirty="0">
+                <a:solidFill>
+                  <a:srgbClr val="1F2328"/>
+                </a:solidFill>
+                <a:latin typeface="Arial" pitchFamily="34" charset="0"/>
+                <a:ea typeface="Arial" pitchFamily="34" charset="-122"/>
+                <a:cs typeface="Arial" pitchFamily="34" charset="-120"/>
+              </a:rPr>
+              <a:t>Work faster in the prompt box</a:t>
+            </a:r>
+            <a:endParaRPr lang="en-US" sz="2800" dirty="0"/>
+          </a:p>
+        </p:txBody>
+      </p:sp>
+      <p:sp>
+        <p:nvSpPr>
+          <p:cNvPr id="8" name="Text 4"/>
+          <p:cNvSpPr/>
+          <p:nvPr/>
+        </p:nvSpPr>
+        <p:spPr>
+          <a:xfrm>
+            <a:off x="507950" y="1104751"/>
+            <a:ext cx="8161020" cy="254050"/>
+          </a:xfrm>
+          <a:prstGeom prst="rect">
+            <a:avLst/>
+          </a:prstGeom>
+          <a:noFill/>
+          <a:ln/>
+        </p:spPr>
+        <p:txBody>
+          <a:bodyPr wrap="square" lIns="0" tIns="0" rIns="0" bIns="0" rtlCol="0" anchor="t"/>
+          <a:lstStyle/>
+          <a:p>
+            <a:pPr algn="l" indent="0" marL="0">
+              <a:lnSpc>
+                <a:spcPts val="2000"/>
+              </a:lnSpc>
+              <a:spcBef>
+                <a:spcPts val="500"/>
+              </a:spcBef>
+              <a:buNone/>
+            </a:pPr>
+            <a:r>
+              <a:rPr lang="en-US" sz="1650" dirty="0">
+                <a:solidFill>
+                  <a:srgbClr val="59636E"/>
+                </a:solidFill>
+                <a:latin typeface="Arial" pitchFamily="34" charset="0"/>
+                <a:ea typeface="Arial" pitchFamily="34" charset="-122"/>
+                <a:cs typeface="Arial" pitchFamily="34" charset="-120"/>
+              </a:rPr>
+              <a:t>Reuse what worked, and try again without retyping.</a:t>
+            </a:r>
+            <a:endParaRPr lang="en-US" sz="1650" dirty="0"/>
+          </a:p>
+        </p:txBody>
+      </p:sp>
+      <p:sp>
+        <p:nvSpPr>
+          <p:cNvPr id="9" name="Text 5"/>
+          <p:cNvSpPr/>
+          <p:nvPr/>
+        </p:nvSpPr>
+        <p:spPr>
+          <a:xfrm>
+            <a:off x="507950" y="2266355"/>
+            <a:ext cx="2590800" cy="1690092"/>
+          </a:xfrm>
+          <a:prstGeom prst="roundRect">
+            <a:avLst>
+              <a:gd name="adj" fmla="val 7514"/>
+            </a:avLst>
+          </a:prstGeom>
+          <a:solidFill>
+            <a:srgbClr val="FFFFFF"/>
+          </a:solidFill>
+          <a:ln w="9525">
+            <a:solidFill>
+              <a:srgbClr val="9CD7FF"/>
+            </a:solidFill>
+          </a:ln>
+        </p:spPr>
+        <p:txBody>
+          <a:bodyPr wrap="square" rtlCol="0" anchor="ctr"/>
+          <a:lstStyle/>
+          <a:p>
+            <a:pPr indent="0" marL="0">
+              <a:buNone/>
+            </a:pPr>
+            <a:endParaRPr lang="en-US" dirty="0"/>
+          </a:p>
+        </p:txBody>
+      </p:sp>
+      <p:sp>
+        <p:nvSpPr>
+          <p:cNvPr id="10" name="Text 6"/>
+          <p:cNvSpPr/>
+          <p:nvPr/>
+        </p:nvSpPr>
+        <p:spPr>
+          <a:xfrm>
+            <a:off x="695176" y="2453580"/>
+            <a:ext cx="381000" cy="381000"/>
+          </a:xfrm>
+          <a:prstGeom prst="roundRect">
+            <a:avLst>
+              <a:gd name="adj" fmla="val 23333"/>
+            </a:avLst>
+          </a:prstGeom>
+          <a:solidFill>
+            <a:srgbClr val="DDF4FF"/>
+          </a:solidFill>
+          <a:ln/>
+        </p:spPr>
+        <p:txBody>
+          <a:bodyPr wrap="square" rtlCol="0" anchor="ctr"/>
+          <a:lstStyle/>
+          <a:p>
+            <a:pPr indent="0" marL="0">
+              <a:buNone/>
+            </a:pPr>
+            <a:endParaRPr lang="en-US" dirty="0"/>
+          </a:p>
+        </p:txBody>
+      </p:sp>
+      <p:pic>
+        <p:nvPicPr>
+          <p:cNvPr id="11" name="Image 2" descr="/Users/danwahlin/.copilot/session-state/56a7a0da-def8-48d4-b5e8-0ac3878cb8dd/files/slides-build/icons/GoSync-0969DA.png">    </p:cNvPr>
+          <p:cNvPicPr>
+            <a:picLocks noChangeAspect="1"/>
+          </p:cNvPicPr>
+          <p:nvPr/>
+        </p:nvPicPr>
+        <p:blipFill>
+          <a:blip r:embed="rId4"/>
+          <a:stretch>
+            <a:fillRect/>
+          </a:stretch>
+        </p:blipFill>
+        <p:spPr>
+          <a:xfrm>
+            <a:off x="777776" y="2536180"/>
+            <a:ext cx="215801" cy="215801"/>
+          </a:xfrm>
+          <a:prstGeom prst="rect">
+            <a:avLst/>
+          </a:prstGeom>
+        </p:spPr>
+      </p:pic>
+      <p:sp>
+        <p:nvSpPr>
+          <p:cNvPr id="12" name="Text 7"/>
+          <p:cNvSpPr/>
+          <p:nvPr/>
+        </p:nvSpPr>
+        <p:spPr>
+          <a:xfrm>
+            <a:off x="1190476" y="2529780"/>
+            <a:ext cx="1734520" cy="228600"/>
+          </a:xfrm>
+          <a:prstGeom prst="rect">
+            <a:avLst/>
+          </a:prstGeom>
+          <a:noFill/>
+          <a:ln/>
+        </p:spPr>
+        <p:txBody>
+          <a:bodyPr wrap="square" lIns="0" tIns="0" rIns="0" bIns="0" rtlCol="0" anchor="t"/>
+          <a:lstStyle/>
+          <a:p>
+            <a:pPr algn="l" indent="0" marL="0">
+              <a:lnSpc>
+                <a:spcPts val="1800"/>
+              </a:lnSpc>
+              <a:buNone/>
+            </a:pPr>
+            <a:r>
+              <a:rPr lang="en-US" sz="1650" b="1" dirty="0">
+                <a:solidFill>
+                  <a:srgbClr val="1F2328"/>
+                </a:solidFill>
+                <a:latin typeface="Arial" pitchFamily="34" charset="0"/>
+                <a:ea typeface="Arial" pitchFamily="34" charset="-122"/>
+                <a:cs typeface="Arial" pitchFamily="34" charset="-120"/>
+              </a:rPr>
+              <a:t>Retry a response</a:t>
+            </a:r>
+            <a:endParaRPr lang="en-US" sz="1650" dirty="0"/>
+          </a:p>
+        </p:txBody>
+      </p:sp>
+      <p:sp>
+        <p:nvSpPr>
+          <p:cNvPr id="13" name="Text 8"/>
+          <p:cNvSpPr/>
+          <p:nvPr/>
+        </p:nvSpPr>
+        <p:spPr>
+          <a:xfrm>
+            <a:off x="695176" y="2910780"/>
+            <a:ext cx="2260675" cy="858441"/>
+          </a:xfrm>
+          <a:prstGeom prst="rect">
+            <a:avLst/>
+          </a:prstGeom>
+          <a:noFill/>
+          <a:ln/>
+        </p:spPr>
+        <p:txBody>
+          <a:bodyPr wrap="square" lIns="0" tIns="0" rIns="0" bIns="0" rtlCol="0" anchor="t"/>
+          <a:lstStyle/>
+          <a:p>
+            <a:pPr algn="l" indent="0" marL="0">
+              <a:lnSpc>
+                <a:spcPts val="1690"/>
+              </a:lnSpc>
+              <a:buNone/>
+            </a:pPr>
+            <a:r>
+              <a:rPr lang="en-US" sz="1400" dirty="0">
+                <a:solidFill>
+                  <a:srgbClr val="59636E"/>
+                </a:solidFill>
+                <a:latin typeface="Arial" pitchFamily="34" charset="0"/>
+                <a:ea typeface="Arial" pitchFamily="34" charset="-122"/>
+                <a:cs typeface="Arial" pitchFamily="34" charset="-120"/>
+              </a:rPr>
+              <a:t>Use </a:t>
+            </a:r>
+            <a:pPr algn="l" indent="0" marL="0">
+              <a:lnSpc>
+                <a:spcPts val="1690"/>
+              </a:lnSpc>
+              <a:buNone/>
+            </a:pPr>
+            <a:r>
+              <a:rPr lang="en-US" sz="1400" b="1" dirty="0">
+                <a:solidFill>
+                  <a:srgbClr val="59636E"/>
+                </a:solidFill>
+                <a:latin typeface="Arial" pitchFamily="34" charset="0"/>
+                <a:ea typeface="Arial" pitchFamily="34" charset="-122"/>
+                <a:cs typeface="Arial" pitchFamily="34" charset="-120"/>
+              </a:rPr>
+              <a:t>Retry</a:t>
+            </a:r>
+            <a:pPr algn="l" indent="0" marL="0">
+              <a:lnSpc>
+                <a:spcPts val="1690"/>
+              </a:lnSpc>
+              <a:buNone/>
+            </a:pPr>
+            <a:r>
+              <a:rPr lang="en-US" sz="1400" dirty="0">
+                <a:solidFill>
+                  <a:srgbClr val="59636E"/>
+                </a:solidFill>
+                <a:latin typeface="Arial" pitchFamily="34" charset="0"/>
+                <a:ea typeface="Arial" pitchFamily="34" charset="-122"/>
+                <a:cs typeface="Arial" pitchFamily="34" charset="-120"/>
+              </a:rPr>
+              <a:t> below a response to rerun it with a different model, effort, or context window.</a:t>
+            </a:r>
+            <a:endParaRPr lang="en-US" sz="1400" dirty="0"/>
+          </a:p>
+        </p:txBody>
+      </p:sp>
+      <p:sp>
+        <p:nvSpPr>
+          <p:cNvPr id="14" name="Text 9"/>
+          <p:cNvSpPr/>
+          <p:nvPr/>
+        </p:nvSpPr>
+        <p:spPr>
+          <a:xfrm>
+            <a:off x="3276451" y="2266355"/>
+            <a:ext cx="2590949" cy="1690092"/>
+          </a:xfrm>
+          <a:prstGeom prst="roundRect">
+            <a:avLst>
+              <a:gd name="adj" fmla="val 7514"/>
+            </a:avLst>
+          </a:prstGeom>
+          <a:solidFill>
+            <a:srgbClr val="FFFFFF"/>
+          </a:solidFill>
+          <a:ln w="9525">
+            <a:solidFill>
+              <a:srgbClr val="E0C5FF"/>
+            </a:solidFill>
+          </a:ln>
+        </p:spPr>
+        <p:txBody>
+          <a:bodyPr wrap="square" rtlCol="0" anchor="ctr"/>
+          <a:lstStyle/>
+          <a:p>
+            <a:pPr indent="0" marL="0">
+              <a:buNone/>
+            </a:pPr>
+            <a:endParaRPr lang="en-US" dirty="0"/>
+          </a:p>
+        </p:txBody>
+      </p:sp>
+      <p:sp>
+        <p:nvSpPr>
+          <p:cNvPr id="15" name="Text 10"/>
+          <p:cNvSpPr/>
+          <p:nvPr/>
+        </p:nvSpPr>
+        <p:spPr>
+          <a:xfrm>
+            <a:off x="3463677" y="2453580"/>
+            <a:ext cx="381000" cy="381000"/>
+          </a:xfrm>
+          <a:prstGeom prst="roundRect">
+            <a:avLst>
+              <a:gd name="adj" fmla="val 23333"/>
+            </a:avLst>
+          </a:prstGeom>
+          <a:solidFill>
+            <a:srgbClr val="FBEFFF"/>
+          </a:solidFill>
+          <a:ln/>
+        </p:spPr>
+        <p:txBody>
+          <a:bodyPr wrap="square" rtlCol="0" anchor="ctr"/>
+          <a:lstStyle/>
+          <a:p>
+            <a:pPr indent="0" marL="0">
+              <a:buNone/>
+            </a:pPr>
+            <a:endParaRPr lang="en-US" dirty="0"/>
+          </a:p>
+        </p:txBody>
+      </p:sp>
+      <p:pic>
+        <p:nvPicPr>
+          <p:cNvPr id="16" name="Image 3" descr="/Users/danwahlin/.copilot/session-state/56a7a0da-def8-48d4-b5e8-0ac3878cb8dd/files/slides-build/icons/GoHistory-8250DF.png">    </p:cNvPr>
+          <p:cNvPicPr>
+            <a:picLocks noChangeAspect="1"/>
+          </p:cNvPicPr>
+          <p:nvPr/>
+        </p:nvPicPr>
+        <p:blipFill>
+          <a:blip r:embed="rId5"/>
+          <a:stretch>
+            <a:fillRect/>
+          </a:stretch>
+        </p:blipFill>
+        <p:spPr>
+          <a:xfrm>
+            <a:off x="3546277" y="2536180"/>
+            <a:ext cx="215801" cy="215801"/>
+          </a:xfrm>
+          <a:prstGeom prst="rect">
+            <a:avLst/>
+          </a:prstGeom>
+        </p:spPr>
+      </p:pic>
+      <p:sp>
+        <p:nvSpPr>
+          <p:cNvPr id="17" name="Text 11"/>
+          <p:cNvSpPr/>
+          <p:nvPr/>
+        </p:nvSpPr>
+        <p:spPr>
+          <a:xfrm>
+            <a:off x="3958977" y="2529780"/>
+            <a:ext cx="1520172" cy="228600"/>
+          </a:xfrm>
+          <a:prstGeom prst="rect">
+            <a:avLst/>
+          </a:prstGeom>
+          <a:noFill/>
+          <a:ln/>
+        </p:spPr>
+        <p:txBody>
+          <a:bodyPr wrap="square" lIns="0" tIns="0" rIns="0" bIns="0" rtlCol="0" anchor="t"/>
+          <a:lstStyle/>
+          <a:p>
+            <a:pPr algn="l" indent="0" marL="0">
+              <a:lnSpc>
+                <a:spcPts val="1800"/>
+              </a:lnSpc>
+              <a:buNone/>
+            </a:pPr>
+            <a:r>
+              <a:rPr lang="en-US" sz="1650" b="1" dirty="0">
+                <a:solidFill>
+                  <a:srgbClr val="1F2328"/>
+                </a:solidFill>
+                <a:latin typeface="Arial" pitchFamily="34" charset="0"/>
+                <a:ea typeface="Arial" pitchFamily="34" charset="-122"/>
+                <a:cs typeface="Arial" pitchFamily="34" charset="-120"/>
+              </a:rPr>
+              <a:t>Prompt history</a:t>
+            </a:r>
+            <a:endParaRPr lang="en-US" sz="1650" dirty="0"/>
+          </a:p>
+        </p:txBody>
+      </p:sp>
+      <p:sp>
+        <p:nvSpPr>
+          <p:cNvPr id="18" name="Text 12"/>
+          <p:cNvSpPr/>
+          <p:nvPr/>
+        </p:nvSpPr>
+        <p:spPr>
+          <a:xfrm>
+            <a:off x="3463677" y="2910780"/>
+            <a:ext cx="2260827" cy="858441"/>
+          </a:xfrm>
+          <a:prstGeom prst="rect">
+            <a:avLst/>
+          </a:prstGeom>
+          <a:noFill/>
+          <a:ln/>
+        </p:spPr>
+        <p:txBody>
+          <a:bodyPr wrap="square" lIns="0" tIns="0" rIns="0" bIns="0" rtlCol="0" anchor="t"/>
+          <a:lstStyle/>
+          <a:p>
+            <a:pPr algn="l" indent="0" marL="0">
+              <a:lnSpc>
+                <a:spcPts val="1690"/>
+              </a:lnSpc>
+              <a:buNone/>
+            </a:pPr>
+            <a:r>
+              <a:rPr lang="en-US" sz="1400" dirty="0">
+                <a:solidFill>
+                  <a:srgbClr val="59636E"/>
+                </a:solidFill>
+                <a:latin typeface="Arial" pitchFamily="34" charset="0"/>
+                <a:ea typeface="Arial" pitchFamily="34" charset="-122"/>
+                <a:cs typeface="Arial" pitchFamily="34" charset="-120"/>
+              </a:rPr>
+              <a:t>Press </a:t>
+            </a:r>
+            <a:pPr algn="l" indent="0" marL="0">
+              <a:lnSpc>
+                <a:spcPts val="1690"/>
+              </a:lnSpc>
+              <a:buNone/>
+            </a:pPr>
+            <a:r>
+              <a:rPr lang="en-US" sz="1400" b="1" dirty="0">
+                <a:solidFill>
+                  <a:srgbClr val="59636E"/>
+                </a:solidFill>
+                <a:latin typeface="Arial" pitchFamily="34" charset="0"/>
+                <a:ea typeface="Arial" pitchFamily="34" charset="-122"/>
+                <a:cs typeface="Arial" pitchFamily="34" charset="-120"/>
+              </a:rPr>
+              <a:t>Ctrl+R</a:t>
+            </a:r>
+            <a:pPr algn="l" indent="0" marL="0">
+              <a:lnSpc>
+                <a:spcPts val="1690"/>
+              </a:lnSpc>
+              <a:buNone/>
+            </a:pPr>
+            <a:r>
+              <a:rPr lang="en-US" sz="1400" dirty="0">
+                <a:solidFill>
+                  <a:srgbClr val="59636E"/>
+                </a:solidFill>
+                <a:latin typeface="Arial" pitchFamily="34" charset="0"/>
+                <a:ea typeface="Arial" pitchFamily="34" charset="-122"/>
+                <a:cs typeface="Arial" pitchFamily="34" charset="-120"/>
+              </a:rPr>
+              <a:t> (</a:t>
+            </a:r>
+            <a:pPr algn="l" indent="0" marL="0">
+              <a:lnSpc>
+                <a:spcPts val="1690"/>
+              </a:lnSpc>
+              <a:buNone/>
+            </a:pPr>
+            <a:r>
+              <a:rPr lang="en-US" sz="1400" b="1" dirty="0">
+                <a:solidFill>
+                  <a:srgbClr val="59636E"/>
+                </a:solidFill>
+                <a:latin typeface="Arial" pitchFamily="34" charset="0"/>
+                <a:ea typeface="Arial" pitchFamily="34" charset="-122"/>
+                <a:cs typeface="Arial" pitchFamily="34" charset="-120"/>
+              </a:rPr>
+              <a:t>Cmd+R</a:t>
+            </a:r>
+            <a:pPr algn="l" indent="0" marL="0">
+              <a:lnSpc>
+                <a:spcPts val="1690"/>
+              </a:lnSpc>
+              <a:buNone/>
+            </a:pPr>
+            <a:r>
+              <a:rPr lang="en-US" sz="1400" dirty="0">
+                <a:solidFill>
+                  <a:srgbClr val="59636E"/>
+                </a:solidFill>
+                <a:latin typeface="Arial" pitchFamily="34" charset="0"/>
+                <a:ea typeface="Arial" pitchFamily="34" charset="-122"/>
+                <a:cs typeface="Arial" pitchFamily="34" charset="-120"/>
+              </a:rPr>
+              <a:t> on macOS) to search recent prompts from all sessions and reuse one.</a:t>
+            </a:r>
+            <a:endParaRPr lang="en-US" sz="1400" dirty="0"/>
+          </a:p>
+        </p:txBody>
+      </p:sp>
+      <p:sp>
+        <p:nvSpPr>
+          <p:cNvPr id="19" name="Text 13"/>
+          <p:cNvSpPr/>
+          <p:nvPr/>
+        </p:nvSpPr>
+        <p:spPr>
+          <a:xfrm>
+            <a:off x="6045101" y="2266355"/>
+            <a:ext cx="2590800" cy="1690092"/>
+          </a:xfrm>
+          <a:prstGeom prst="roundRect">
+            <a:avLst>
+              <a:gd name="adj" fmla="val 7514"/>
+            </a:avLst>
+          </a:prstGeom>
+          <a:solidFill>
+            <a:srgbClr val="FFFFFF"/>
+          </a:solidFill>
+          <a:ln w="9525">
+            <a:solidFill>
+              <a:srgbClr val="8CE7A5"/>
+            </a:solidFill>
+          </a:ln>
+        </p:spPr>
+        <p:txBody>
+          <a:bodyPr wrap="square" rtlCol="0" anchor="ctr"/>
+          <a:lstStyle/>
+          <a:p>
+            <a:pPr indent="0" marL="0">
+              <a:buNone/>
+            </a:pPr>
+            <a:endParaRPr lang="en-US" dirty="0"/>
+          </a:p>
+        </p:txBody>
+      </p:sp>
+      <p:sp>
+        <p:nvSpPr>
+          <p:cNvPr id="20" name="Text 14"/>
+          <p:cNvSpPr/>
+          <p:nvPr/>
+        </p:nvSpPr>
+        <p:spPr>
+          <a:xfrm>
+            <a:off x="6232327" y="2453580"/>
+            <a:ext cx="381000" cy="381000"/>
+          </a:xfrm>
+          <a:prstGeom prst="roundRect">
+            <a:avLst>
+              <a:gd name="adj" fmla="val 23333"/>
+            </a:avLst>
+          </a:prstGeom>
+          <a:solidFill>
+            <a:srgbClr val="DAFBE1"/>
+          </a:solidFill>
+          <a:ln/>
+        </p:spPr>
+        <p:txBody>
+          <a:bodyPr wrap="square" rtlCol="0" anchor="ctr"/>
+          <a:lstStyle/>
+          <a:p>
+            <a:pPr indent="0" marL="0">
+              <a:buNone/>
+            </a:pPr>
+            <a:endParaRPr lang="en-US" dirty="0"/>
+          </a:p>
+        </p:txBody>
+      </p:sp>
+      <p:pic>
+        <p:nvPicPr>
+          <p:cNvPr id="21" name="Image 4" descr="/Users/danwahlin/.copilot/session-state/56a7a0da-def8-48d4-b5e8-0ac3878cb8dd/files/slides-build/icons/GoUnmute-1A7F37.png">    </p:cNvPr>
+          <p:cNvPicPr>
+            <a:picLocks noChangeAspect="1"/>
+          </p:cNvPicPr>
+          <p:nvPr/>
+        </p:nvPicPr>
+        <p:blipFill>
+          <a:blip r:embed="rId6"/>
+          <a:stretch>
+            <a:fillRect/>
+          </a:stretch>
+        </p:blipFill>
+        <p:spPr>
+          <a:xfrm>
+            <a:off x="6314926" y="2536180"/>
+            <a:ext cx="215801" cy="215801"/>
+          </a:xfrm>
+          <a:prstGeom prst="rect">
+            <a:avLst/>
+          </a:prstGeom>
+        </p:spPr>
+      </p:pic>
+      <p:sp>
+        <p:nvSpPr>
+          <p:cNvPr id="22" name="Text 15"/>
+          <p:cNvSpPr/>
+          <p:nvPr/>
+        </p:nvSpPr>
+        <p:spPr>
+          <a:xfrm>
+            <a:off x="6727627" y="2529780"/>
+            <a:ext cx="1504384" cy="228600"/>
+          </a:xfrm>
+          <a:prstGeom prst="rect">
+            <a:avLst/>
+          </a:prstGeom>
+          <a:noFill/>
+          <a:ln/>
+        </p:spPr>
+        <p:txBody>
+          <a:bodyPr wrap="square" lIns="0" tIns="0" rIns="0" bIns="0" rtlCol="0" anchor="t"/>
+          <a:lstStyle/>
+          <a:p>
+            <a:pPr algn="l" indent="0" marL="0">
+              <a:lnSpc>
+                <a:spcPts val="1800"/>
+              </a:lnSpc>
+              <a:buNone/>
+            </a:pPr>
+            <a:r>
+              <a:rPr lang="en-US" sz="1650" b="1" dirty="0">
+                <a:solidFill>
+                  <a:srgbClr val="1F2328"/>
+                </a:solidFill>
+                <a:latin typeface="Arial" pitchFamily="34" charset="0"/>
+                <a:ea typeface="Arial" pitchFamily="34" charset="-122"/>
+                <a:cs typeface="Arial" pitchFamily="34" charset="-120"/>
+              </a:rPr>
+              <a:t>Voice dictation</a:t>
+            </a:r>
+            <a:endParaRPr lang="en-US" sz="1650" dirty="0"/>
+          </a:p>
+        </p:txBody>
+      </p:sp>
+      <p:sp>
+        <p:nvSpPr>
+          <p:cNvPr id="23" name="Text 16"/>
+          <p:cNvSpPr/>
+          <p:nvPr/>
+        </p:nvSpPr>
+        <p:spPr>
+          <a:xfrm>
+            <a:off x="6232327" y="2910780"/>
+            <a:ext cx="2260675" cy="643830"/>
+          </a:xfrm>
+          <a:prstGeom prst="rect">
+            <a:avLst/>
+          </a:prstGeom>
+          <a:noFill/>
+          <a:ln/>
+        </p:spPr>
+        <p:txBody>
+          <a:bodyPr wrap="square" lIns="0" tIns="0" rIns="0" bIns="0" rtlCol="0" anchor="t"/>
+          <a:lstStyle/>
+          <a:p>
+            <a:pPr algn="l" indent="0" marL="0">
+              <a:lnSpc>
+                <a:spcPts val="1690"/>
+              </a:lnSpc>
+              <a:buNone/>
+            </a:pPr>
+            <a:r>
+              <a:rPr lang="en-US" sz="1400" dirty="0">
+                <a:solidFill>
+                  <a:srgbClr val="59636E"/>
+                </a:solidFill>
+                <a:latin typeface="Arial" pitchFamily="34" charset="0"/>
+                <a:ea typeface="Arial" pitchFamily="34" charset="-122"/>
+                <a:cs typeface="Arial" pitchFamily="34" charset="-120"/>
+              </a:rPr>
+              <a:t>Speak a prompt, then edit the text before you send it. Optional.</a:t>
+            </a:r>
+            <a:endParaRPr lang="en-US" sz="1400" dirty="0"/>
+          </a:p>
+        </p:txBody>
+      </p:sp>
+    </p:spTree>
+  </p:cSld>
+  <p:clrMapOvr>
+    <a:masterClrMapping/>
+  </p:clrMapOvr>
+</p:sld>
+</file>
+
+<file path=ppt/slides/slide16.xml><?xml version="1.0" encoding="utf-8"?>
+<p:sld xmlns:a="http://schemas.openxmlformats.org/drawingml/2006/main" xmlns:r="http://schemas.openxmlformats.org/officeDocument/2006/relationships" xmlns:p="http://schemas.openxmlformats.org/presentationml/2006/main">
+  <p:cSld name="Slide 16">
     <p:bg>
       <p:bgPr>
         <a:solidFill>

</xml_diff>